<commit_message>
Updates to queue notes
</commit_message>
<xml_diff>
--- a/u06c_queues/notes/_queues.pptx
+++ b/u06c_queues/notes/_queues.pptx
@@ -7,10 +7,10 @@
     <p:sldMasterId id="2147483672" r:id="rId3"/>
   </p:sldMasterIdLst>
   <p:notesMasterIdLst>
-    <p:notesMasterId r:id="rId31"/>
+    <p:notesMasterId r:id="rId33"/>
   </p:notesMasterIdLst>
   <p:handoutMasterIdLst>
-    <p:handoutMasterId r:id="rId32"/>
+    <p:handoutMasterId r:id="rId34"/>
   </p:handoutMasterIdLst>
   <p:sldIdLst>
     <p:sldId id="257" r:id="rId4"/>
@@ -40,6 +40,8 @@
     <p:sldId id="338" r:id="rId28"/>
     <p:sldId id="339" r:id="rId29"/>
     <p:sldId id="334" r:id="rId30"/>
+    <p:sldId id="346" r:id="rId31"/>
+    <p:sldId id="345" r:id="rId32"/>
   </p:sldIdLst>
   <p:sldSz cx="9144000" cy="6858000" type="screen4x3"/>
   <p:notesSz cx="6858000" cy="9144000"/>
@@ -3550,7 +3552,7 @@
             <a:fld id="{305D531A-7AB3-4B96-8E52-F020EEA2103D}" type="datetime1">
               <a:rPr lang="en-US" altLang="en-US"/>
               <a:pPr/>
-              <a:t>12/3/2024</a:t>
+              <a:t>12/5/2024</a:t>
             </a:fld>
             <a:endParaRPr lang="en-US" altLang="en-US"/>
           </a:p>
@@ -3729,7 +3731,7 @@
             <a:fld id="{D920E74B-684C-46F2-B5D5-A6BE92FDF52F}" type="datetime1">
               <a:rPr lang="en-US" altLang="en-US"/>
               <a:pPr/>
-              <a:t>12/3/2024</a:t>
+              <a:t>12/5/2024</a:t>
             </a:fld>
             <a:endParaRPr lang="en-US" altLang="en-US"/>
           </a:p>
@@ -4091,7 +4093,7 @@
             <a:fld id="{4B12E7DF-AE82-4EFA-8F55-E9D341F03E4E}" type="datetime1">
               <a:rPr lang="en-US" altLang="en-US"/>
               <a:pPr/>
-              <a:t>12/3/2024</a:t>
+              <a:t>12/5/2024</a:t>
             </a:fld>
             <a:endParaRPr lang="en-US" altLang="en-US"/>
           </a:p>
@@ -4370,7 +4372,7 @@
             <a:fld id="{CCA652E5-FB34-42BF-83DC-02690BC9CC4A}" type="datetime1">
               <a:rPr lang="en-US" altLang="en-US"/>
               <a:pPr/>
-              <a:t>12/3/2024</a:t>
+              <a:t>12/5/2024</a:t>
             </a:fld>
             <a:endParaRPr lang="en-US" altLang="en-US"/>
           </a:p>
@@ -4759,7 +4761,7 @@
             <a:fld id="{28DBD71C-1767-4314-A6C5-2CB4D8DEF85B}" type="datetime1">
               <a:rPr lang="en-US" altLang="en-US"/>
               <a:pPr/>
-              <a:t>12/3/2024</a:t>
+              <a:t>12/5/2024</a:t>
             </a:fld>
             <a:endParaRPr lang="en-US" altLang="en-US"/>
           </a:p>
@@ -4974,7 +4976,7 @@
             <a:fld id="{EA28E83C-AD7B-498E-B1B8-16B5B835811A}" type="datetime1">
               <a:rPr lang="en-US" altLang="en-US"/>
               <a:pPr/>
-              <a:t>12/3/2024</a:t>
+              <a:t>12/5/2024</a:t>
             </a:fld>
             <a:endParaRPr lang="en-US" altLang="en-US"/>
           </a:p>
@@ -5211,7 +5213,7 @@
             <a:fld id="{363908BC-A2CC-4FA6-8BA7-D4759357BD61}" type="datetime1">
               <a:rPr lang="en-US" altLang="en-US"/>
               <a:pPr/>
-              <a:t>12/3/2024</a:t>
+              <a:t>12/5/2024</a:t>
             </a:fld>
             <a:endParaRPr lang="en-US" altLang="en-US"/>
           </a:p>
@@ -5653,7 +5655,7 @@
             <a:fld id="{8F20675D-E6F0-473E-BC0A-6F13DBA83856}" type="datetime1">
               <a:rPr lang="en-US" altLang="en-US"/>
               <a:pPr/>
-              <a:t>12/3/2024</a:t>
+              <a:t>12/5/2024</a:t>
             </a:fld>
             <a:endParaRPr lang="en-US" altLang="en-US"/>
           </a:p>
@@ -6323,7 +6325,7 @@
             <a:fld id="{A47F3096-3E67-44E0-B734-CDB10A379595}" type="datetime1">
               <a:rPr lang="en-US" altLang="en-US"/>
               <a:pPr/>
-              <a:t>12/3/2024</a:t>
+              <a:t>12/5/2024</a:t>
             </a:fld>
             <a:endParaRPr lang="en-US" altLang="en-US"/>
           </a:p>
@@ -6526,7 +6528,7 @@
             <a:fld id="{C6705D8E-9400-482A-B760-1F5DD9289029}" type="datetime1">
               <a:rPr lang="en-US" altLang="en-US"/>
               <a:pPr/>
-              <a:t>12/3/2024</a:t>
+              <a:t>12/5/2024</a:t>
             </a:fld>
             <a:endParaRPr lang="en-US" altLang="en-US"/>
           </a:p>
@@ -6895,7 +6897,7 @@
             <a:fld id="{66D020E9-6FD4-49DF-BF80-B8129ABE624F}" type="datetime1">
               <a:rPr lang="en-US" altLang="en-US"/>
               <a:pPr/>
-              <a:t>12/3/2024</a:t>
+              <a:t>12/5/2024</a:t>
             </a:fld>
             <a:endParaRPr lang="en-US" altLang="en-US"/>
           </a:p>
@@ -7344,7 +7346,7 @@
             <a:fld id="{305D531A-7AB3-4B96-8E52-F020EEA2103D}" type="datetime1">
               <a:rPr lang="en-US" altLang="en-US"/>
               <a:pPr/>
-              <a:t>12/3/2024</a:t>
+              <a:t>12/5/2024</a:t>
             </a:fld>
             <a:endParaRPr lang="en-US" altLang="en-US"/>
           </a:p>
@@ -7523,7 +7525,7 @@
             <a:fld id="{D920E74B-684C-46F2-B5D5-A6BE92FDF52F}" type="datetime1">
               <a:rPr lang="en-US" altLang="en-US"/>
               <a:pPr/>
-              <a:t>12/3/2024</a:t>
+              <a:t>12/5/2024</a:t>
             </a:fld>
             <a:endParaRPr lang="en-US" altLang="en-US"/>
           </a:p>
@@ -7885,7 +7887,7 @@
             <a:fld id="{4B12E7DF-AE82-4EFA-8F55-E9D341F03E4E}" type="datetime1">
               <a:rPr lang="en-US" altLang="en-US"/>
               <a:pPr/>
-              <a:t>12/3/2024</a:t>
+              <a:t>12/5/2024</a:t>
             </a:fld>
             <a:endParaRPr lang="en-US" altLang="en-US"/>
           </a:p>
@@ -8164,7 +8166,7 @@
             <a:fld id="{CCA652E5-FB34-42BF-83DC-02690BC9CC4A}" type="datetime1">
               <a:rPr lang="en-US" altLang="en-US"/>
               <a:pPr/>
-              <a:t>12/3/2024</a:t>
+              <a:t>12/5/2024</a:t>
             </a:fld>
             <a:endParaRPr lang="en-US" altLang="en-US"/>
           </a:p>
@@ -8553,7 +8555,7 @@
             <a:fld id="{28DBD71C-1767-4314-A6C5-2CB4D8DEF85B}" type="datetime1">
               <a:rPr lang="en-US" altLang="en-US"/>
               <a:pPr/>
-              <a:t>12/3/2024</a:t>
+              <a:t>12/5/2024</a:t>
             </a:fld>
             <a:endParaRPr lang="en-US" altLang="en-US"/>
           </a:p>
@@ -8768,7 +8770,7 @@
             <a:fld id="{EA28E83C-AD7B-498E-B1B8-16B5B835811A}" type="datetime1">
               <a:rPr lang="en-US" altLang="en-US"/>
               <a:pPr/>
-              <a:t>12/3/2024</a:t>
+              <a:t>12/5/2024</a:t>
             </a:fld>
             <a:endParaRPr lang="en-US" altLang="en-US"/>
           </a:p>
@@ -9005,7 +9007,7 @@
             <a:fld id="{363908BC-A2CC-4FA6-8BA7-D4759357BD61}" type="datetime1">
               <a:rPr lang="en-US" altLang="en-US"/>
               <a:pPr/>
-              <a:t>12/3/2024</a:t>
+              <a:t>12/5/2024</a:t>
             </a:fld>
             <a:endParaRPr lang="en-US" altLang="en-US"/>
           </a:p>
@@ -9706,7 +9708,7 @@
             <a:fld id="{8F20675D-E6F0-473E-BC0A-6F13DBA83856}" type="datetime1">
               <a:rPr lang="en-US" altLang="en-US"/>
               <a:pPr/>
-              <a:t>12/3/2024</a:t>
+              <a:t>12/5/2024</a:t>
             </a:fld>
             <a:endParaRPr lang="en-US" altLang="en-US"/>
           </a:p>
@@ -10140,7 +10142,7 @@
             <a:fld id="{A47F3096-3E67-44E0-B734-CDB10A379595}" type="datetime1">
               <a:rPr lang="en-US" altLang="en-US"/>
               <a:pPr/>
-              <a:t>12/3/2024</a:t>
+              <a:t>12/5/2024</a:t>
             </a:fld>
             <a:endParaRPr lang="en-US" altLang="en-US"/>
           </a:p>
@@ -10343,7 +10345,7 @@
             <a:fld id="{C6705D8E-9400-482A-B760-1F5DD9289029}" type="datetime1">
               <a:rPr lang="en-US" altLang="en-US"/>
               <a:pPr/>
-              <a:t>12/3/2024</a:t>
+              <a:t>12/5/2024</a:t>
             </a:fld>
             <a:endParaRPr lang="en-US" altLang="en-US"/>
           </a:p>
@@ -10712,7 +10714,7 @@
             <a:fld id="{66D020E9-6FD4-49DF-BF80-B8129ABE624F}" type="datetime1">
               <a:rPr lang="en-US" altLang="en-US"/>
               <a:pPr/>
-              <a:t>12/3/2024</a:t>
+              <a:t>12/5/2024</a:t>
             </a:fld>
             <a:endParaRPr lang="en-US" altLang="en-US"/>
           </a:p>
@@ -13728,7 +13730,7 @@
             <a:fld id="{FF8048E6-EE6A-44C1-B482-82F3EE80854C}" type="datetime1">
               <a:rPr lang="en-US" altLang="en-US"/>
               <a:pPr/>
-              <a:t>12/3/2024</a:t>
+              <a:t>12/5/2024</a:t>
             </a:fld>
             <a:endParaRPr lang="en-US" altLang="en-US"/>
           </a:p>
@@ -14671,7 +14673,7 @@
             <a:fld id="{FF8048E6-EE6A-44C1-B482-82F3EE80854C}" type="datetime1">
               <a:rPr lang="en-US" altLang="en-US"/>
               <a:pPr/>
-              <a:t>12/3/2024</a:t>
+              <a:t>12/5/2024</a:t>
             </a:fld>
             <a:endParaRPr lang="en-US" altLang="en-US"/>
           </a:p>
@@ -30294,6 +30296,2148 @@
         </p:txBody>
       </p:sp>
     </p:spTree>
+  </p:cSld>
+  <p:clrMapOvr>
+    <a:masterClrMapping/>
+  </p:clrMapOvr>
+</p:sld>
+</file>
+
+<file path=ppt/slides/slide28.xml><?xml version="1.0" encoding="utf-8"?>
+<p:sld xmlns:a="http://schemas.openxmlformats.org/drawingml/2006/main" xmlns:r="http://schemas.openxmlformats.org/officeDocument/2006/relationships" xmlns:p="http://schemas.openxmlformats.org/presentationml/2006/main">
+  <p:cSld>
+    <p:spTree>
+      <p:nvGrpSpPr>
+        <p:cNvPr id="1" name=""/>
+        <p:cNvGrpSpPr/>
+        <p:nvPr/>
+      </p:nvGrpSpPr>
+      <p:grpSpPr>
+        <a:xfrm>
+          <a:off x="0" y="0"/>
+          <a:ext cx="0" cy="0"/>
+          <a:chOff x="0" y="0"/>
+          <a:chExt cx="0" cy="0"/>
+        </a:xfrm>
+      </p:grpSpPr>
+      <p:sp>
+        <p:nvSpPr>
+          <p:cNvPr id="20482" name="Footer Placeholder 3">
+            <a:extLst>
+              <a:ext uri="{FF2B5EF4-FFF2-40B4-BE49-F238E27FC236}">
+                <a16:creationId xmlns:a16="http://schemas.microsoft.com/office/drawing/2014/main" id="{190EA73F-91E8-4AA5-A9E9-87D31767202B}"/>
+              </a:ext>
+            </a:extLst>
+          </p:cNvPr>
+          <p:cNvSpPr>
+            <a:spLocks noGrp="1"/>
+          </p:cNvSpPr>
+          <p:nvPr>
+            <p:ph type="ftr" sz="quarter" idx="12"/>
+          </p:nvPr>
+        </p:nvSpPr>
+        <p:spPr>
+          <a:noFill/>
+        </p:spPr>
+        <p:txBody>
+          <a:bodyPr/>
+          <a:lstStyle>
+            <a:lvl1pPr>
+              <a:spcBef>
+                <a:spcPct val="20000"/>
+              </a:spcBef>
+              <a:buChar char="•"/>
+              <a:defRPr sz="3200">
+                <a:solidFill>
+                  <a:schemeClr val="tx1"/>
+                </a:solidFill>
+                <a:latin typeface="Times New Roman" panose="02020603050405020304" pitchFamily="18" charset="0"/>
+              </a:defRPr>
+            </a:lvl1pPr>
+            <a:lvl2pPr marL="742950" indent="-285750">
+              <a:spcBef>
+                <a:spcPct val="20000"/>
+              </a:spcBef>
+              <a:buChar char="–"/>
+              <a:defRPr sz="2800">
+                <a:solidFill>
+                  <a:schemeClr val="tx1"/>
+                </a:solidFill>
+                <a:latin typeface="Times New Roman" panose="02020603050405020304" pitchFamily="18" charset="0"/>
+              </a:defRPr>
+            </a:lvl2pPr>
+            <a:lvl3pPr marL="1143000" indent="-228600">
+              <a:spcBef>
+                <a:spcPct val="20000"/>
+              </a:spcBef>
+              <a:buChar char="•"/>
+              <a:defRPr sz="2400">
+                <a:solidFill>
+                  <a:schemeClr val="tx1"/>
+                </a:solidFill>
+                <a:latin typeface="Times New Roman" panose="02020603050405020304" pitchFamily="18" charset="0"/>
+              </a:defRPr>
+            </a:lvl3pPr>
+            <a:lvl4pPr marL="1600200" indent="-228600">
+              <a:spcBef>
+                <a:spcPct val="20000"/>
+              </a:spcBef>
+              <a:buChar char="–"/>
+              <a:defRPr sz="2000">
+                <a:solidFill>
+                  <a:schemeClr val="tx1"/>
+                </a:solidFill>
+                <a:latin typeface="Times New Roman" panose="02020603050405020304" pitchFamily="18" charset="0"/>
+              </a:defRPr>
+            </a:lvl4pPr>
+            <a:lvl5pPr marL="2057400" indent="-228600">
+              <a:spcBef>
+                <a:spcPct val="20000"/>
+              </a:spcBef>
+              <a:buChar char="»"/>
+              <a:defRPr sz="2000">
+                <a:solidFill>
+                  <a:schemeClr val="tx1"/>
+                </a:solidFill>
+                <a:latin typeface="Times New Roman" panose="02020603050405020304" pitchFamily="18" charset="0"/>
+              </a:defRPr>
+            </a:lvl5pPr>
+            <a:lvl6pPr marL="2514600" indent="-228600" eaLnBrk="0" fontAlgn="base" hangingPunct="0">
+              <a:spcBef>
+                <a:spcPct val="20000"/>
+              </a:spcBef>
+              <a:spcAft>
+                <a:spcPct val="0"/>
+              </a:spcAft>
+              <a:buChar char="»"/>
+              <a:defRPr sz="2000">
+                <a:solidFill>
+                  <a:schemeClr val="tx1"/>
+                </a:solidFill>
+                <a:latin typeface="Times New Roman" panose="02020603050405020304" pitchFamily="18" charset="0"/>
+              </a:defRPr>
+            </a:lvl6pPr>
+            <a:lvl7pPr marL="2971800" indent="-228600" eaLnBrk="0" fontAlgn="base" hangingPunct="0">
+              <a:spcBef>
+                <a:spcPct val="20000"/>
+              </a:spcBef>
+              <a:spcAft>
+                <a:spcPct val="0"/>
+              </a:spcAft>
+              <a:buChar char="»"/>
+              <a:defRPr sz="2000">
+                <a:solidFill>
+                  <a:schemeClr val="tx1"/>
+                </a:solidFill>
+                <a:latin typeface="Times New Roman" panose="02020603050405020304" pitchFamily="18" charset="0"/>
+              </a:defRPr>
+            </a:lvl7pPr>
+            <a:lvl8pPr marL="3429000" indent="-228600" eaLnBrk="0" fontAlgn="base" hangingPunct="0">
+              <a:spcBef>
+                <a:spcPct val="20000"/>
+              </a:spcBef>
+              <a:spcAft>
+                <a:spcPct val="0"/>
+              </a:spcAft>
+              <a:buChar char="»"/>
+              <a:defRPr sz="2000">
+                <a:solidFill>
+                  <a:schemeClr val="tx1"/>
+                </a:solidFill>
+                <a:latin typeface="Times New Roman" panose="02020603050405020304" pitchFamily="18" charset="0"/>
+              </a:defRPr>
+            </a:lvl8pPr>
+            <a:lvl9pPr marL="3886200" indent="-228600" eaLnBrk="0" fontAlgn="base" hangingPunct="0">
+              <a:spcBef>
+                <a:spcPct val="20000"/>
+              </a:spcBef>
+              <a:spcAft>
+                <a:spcPct val="0"/>
+              </a:spcAft>
+              <a:buChar char="»"/>
+              <a:defRPr sz="2000">
+                <a:solidFill>
+                  <a:schemeClr val="tx1"/>
+                </a:solidFill>
+                <a:latin typeface="Times New Roman" panose="02020603050405020304" pitchFamily="18" charset="0"/>
+              </a:defRPr>
+            </a:lvl9pPr>
+          </a:lstStyle>
+          <a:p>
+            <a:pPr>
+              <a:spcBef>
+                <a:spcPct val="0"/>
+              </a:spcBef>
+              <a:buFontTx/>
+              <a:buNone/>
+            </a:pPr>
+            <a:endParaRPr lang="en-US" altLang="en-US" sz="800" b="1"/>
+          </a:p>
+          <a:p>
+            <a:pPr>
+              <a:spcBef>
+                <a:spcPct val="0"/>
+              </a:spcBef>
+              <a:buFontTx/>
+              <a:buNone/>
+            </a:pPr>
+            <a:endParaRPr lang="en-US" altLang="en-US" sz="800">
+              <a:latin typeface="Tahoma" panose="020B0604030504040204" pitchFamily="34" charset="0"/>
+            </a:endParaRPr>
+          </a:p>
+          <a:p>
+            <a:pPr>
+              <a:spcBef>
+                <a:spcPct val="0"/>
+              </a:spcBef>
+              <a:buFontTx/>
+              <a:buNone/>
+            </a:pPr>
+            <a:endParaRPr lang="en-US" altLang="en-US" sz="800" b="1">
+              <a:latin typeface="Tahoma" panose="020B0604030504040204" pitchFamily="34" charset="0"/>
+            </a:endParaRPr>
+          </a:p>
+          <a:p>
+            <a:pPr>
+              <a:spcBef>
+                <a:spcPct val="0"/>
+              </a:spcBef>
+              <a:buFontTx/>
+              <a:buNone/>
+            </a:pPr>
+            <a:r>
+              <a:rPr lang="en-US" altLang="en-US" sz="800" b="1">
+                <a:latin typeface="Tahoma" panose="020B0604030504040204" pitchFamily="34" charset="0"/>
+              </a:rPr>
+              <a:t>© A+ Computer Science  -  www.apluscompsci.com</a:t>
+            </a:r>
+          </a:p>
+        </p:txBody>
+      </p:sp>
+      <p:sp>
+        <p:nvSpPr>
+          <p:cNvPr id="20483" name="Text Box 2">
+            <a:extLst>
+              <a:ext uri="{FF2B5EF4-FFF2-40B4-BE49-F238E27FC236}">
+                <a16:creationId xmlns:a16="http://schemas.microsoft.com/office/drawing/2014/main" id="{4798B9E7-9EED-415C-92F1-0A91537E0036}"/>
+              </a:ext>
+            </a:extLst>
+          </p:cNvPr>
+          <p:cNvSpPr txBox="1">
+            <a:spLocks noChangeArrowheads="1"/>
+          </p:cNvSpPr>
+          <p:nvPr/>
+        </p:nvSpPr>
+        <p:spPr bwMode="auto">
+          <a:xfrm>
+            <a:off x="609600" y="1600200"/>
+            <a:ext cx="7010400" cy="4789488"/>
+          </a:xfrm>
+          <a:prstGeom prst="rect">
+            <a:avLst/>
+          </a:prstGeom>
+          <a:noFill/>
+          <a:ln>
+            <a:noFill/>
+          </a:ln>
+          <a:effectLst/>
+          <a:extLst>
+            <a:ext uri="{909E8E84-426E-40DD-AFC4-6F175D3DCCD1}">
+              <a14:hiddenFill xmlns:a14="http://schemas.microsoft.com/office/drawing/2010/main">
+                <a:solidFill>
+                  <a:schemeClr val="accent1"/>
+                </a:solidFill>
+              </a14:hiddenFill>
+            </a:ext>
+            <a:ext uri="{91240B29-F687-4F45-9708-019B960494DF}">
+              <a14:hiddenLine xmlns:a14="http://schemas.microsoft.com/office/drawing/2010/main" w="9525">
+                <a:solidFill>
+                  <a:schemeClr val="tx1"/>
+                </a:solidFill>
+                <a:miter lim="800000"/>
+                <a:headEnd/>
+                <a:tailEnd/>
+              </a14:hiddenLine>
+            </a:ext>
+            <a:ext uri="{AF507438-7753-43E0-B8FC-AC1667EBCBE1}">
+              <a14:hiddenEffects xmlns:a14="http://schemas.microsoft.com/office/drawing/2010/main">
+                <a:effectLst>
+                  <a:outerShdw dist="35921" dir="2700000" algn="ctr" rotWithShape="0">
+                    <a:schemeClr val="bg2"/>
+                  </a:outerShdw>
+                </a:effectLst>
+              </a14:hiddenEffects>
+            </a:ext>
+          </a:extLst>
+        </p:spPr>
+        <p:txBody>
+          <a:bodyPr>
+            <a:spAutoFit/>
+          </a:bodyPr>
+          <a:lstStyle>
+            <a:lvl1pPr>
+              <a:spcBef>
+                <a:spcPct val="20000"/>
+              </a:spcBef>
+              <a:buChar char="•"/>
+              <a:defRPr sz="3200">
+                <a:solidFill>
+                  <a:schemeClr val="tx1"/>
+                </a:solidFill>
+                <a:latin typeface="Times New Roman" panose="02020603050405020304" pitchFamily="18" charset="0"/>
+              </a:defRPr>
+            </a:lvl1pPr>
+            <a:lvl2pPr marL="742950" indent="-285750">
+              <a:spcBef>
+                <a:spcPct val="20000"/>
+              </a:spcBef>
+              <a:buChar char="–"/>
+              <a:defRPr sz="2800">
+                <a:solidFill>
+                  <a:schemeClr val="tx1"/>
+                </a:solidFill>
+                <a:latin typeface="Times New Roman" panose="02020603050405020304" pitchFamily="18" charset="0"/>
+              </a:defRPr>
+            </a:lvl2pPr>
+            <a:lvl3pPr marL="1143000" indent="-228600">
+              <a:spcBef>
+                <a:spcPct val="20000"/>
+              </a:spcBef>
+              <a:buChar char="•"/>
+              <a:defRPr sz="2400">
+                <a:solidFill>
+                  <a:schemeClr val="tx1"/>
+                </a:solidFill>
+                <a:latin typeface="Times New Roman" panose="02020603050405020304" pitchFamily="18" charset="0"/>
+              </a:defRPr>
+            </a:lvl3pPr>
+            <a:lvl4pPr marL="1600200" indent="-228600">
+              <a:spcBef>
+                <a:spcPct val="20000"/>
+              </a:spcBef>
+              <a:buChar char="–"/>
+              <a:defRPr sz="2000">
+                <a:solidFill>
+                  <a:schemeClr val="tx1"/>
+                </a:solidFill>
+                <a:latin typeface="Times New Roman" panose="02020603050405020304" pitchFamily="18" charset="0"/>
+              </a:defRPr>
+            </a:lvl4pPr>
+            <a:lvl5pPr marL="2057400" indent="-228600">
+              <a:spcBef>
+                <a:spcPct val="20000"/>
+              </a:spcBef>
+              <a:buChar char="»"/>
+              <a:defRPr sz="2000">
+                <a:solidFill>
+                  <a:schemeClr val="tx1"/>
+                </a:solidFill>
+                <a:latin typeface="Times New Roman" panose="02020603050405020304" pitchFamily="18" charset="0"/>
+              </a:defRPr>
+            </a:lvl5pPr>
+            <a:lvl6pPr marL="2514600" indent="-228600" eaLnBrk="0" fontAlgn="base" hangingPunct="0">
+              <a:spcBef>
+                <a:spcPct val="20000"/>
+              </a:spcBef>
+              <a:spcAft>
+                <a:spcPct val="0"/>
+              </a:spcAft>
+              <a:buChar char="»"/>
+              <a:defRPr sz="2000">
+                <a:solidFill>
+                  <a:schemeClr val="tx1"/>
+                </a:solidFill>
+                <a:latin typeface="Times New Roman" panose="02020603050405020304" pitchFamily="18" charset="0"/>
+              </a:defRPr>
+            </a:lvl6pPr>
+            <a:lvl7pPr marL="2971800" indent="-228600" eaLnBrk="0" fontAlgn="base" hangingPunct="0">
+              <a:spcBef>
+                <a:spcPct val="20000"/>
+              </a:spcBef>
+              <a:spcAft>
+                <a:spcPct val="0"/>
+              </a:spcAft>
+              <a:buChar char="»"/>
+              <a:defRPr sz="2000">
+                <a:solidFill>
+                  <a:schemeClr val="tx1"/>
+                </a:solidFill>
+                <a:latin typeface="Times New Roman" panose="02020603050405020304" pitchFamily="18" charset="0"/>
+              </a:defRPr>
+            </a:lvl7pPr>
+            <a:lvl8pPr marL="3429000" indent="-228600" eaLnBrk="0" fontAlgn="base" hangingPunct="0">
+              <a:spcBef>
+                <a:spcPct val="20000"/>
+              </a:spcBef>
+              <a:spcAft>
+                <a:spcPct val="0"/>
+              </a:spcAft>
+              <a:buChar char="»"/>
+              <a:defRPr sz="2000">
+                <a:solidFill>
+                  <a:schemeClr val="tx1"/>
+                </a:solidFill>
+                <a:latin typeface="Times New Roman" panose="02020603050405020304" pitchFamily="18" charset="0"/>
+              </a:defRPr>
+            </a:lvl8pPr>
+            <a:lvl9pPr marL="3886200" indent="-228600" eaLnBrk="0" fontAlgn="base" hangingPunct="0">
+              <a:spcBef>
+                <a:spcPct val="20000"/>
+              </a:spcBef>
+              <a:spcAft>
+                <a:spcPct val="0"/>
+              </a:spcAft>
+              <a:buChar char="»"/>
+              <a:defRPr sz="2000">
+                <a:solidFill>
+                  <a:schemeClr val="tx1"/>
+                </a:solidFill>
+                <a:latin typeface="Times New Roman" panose="02020603050405020304" pitchFamily="18" charset="0"/>
+              </a:defRPr>
+            </a:lvl9pPr>
+          </a:lstStyle>
+          <a:p>
+            <a:pPr>
+              <a:spcBef>
+                <a:spcPct val="0"/>
+              </a:spcBef>
+              <a:buFontTx/>
+              <a:buNone/>
+            </a:pPr>
+            <a:r>
+              <a:rPr lang="en-US" altLang="en-US" sz="2800" dirty="0">
+                <a:latin typeface="Tahoma" panose="020B0604030504040204" pitchFamily="34" charset="0"/>
+              </a:rPr>
+              <a:t>Queue&lt;Integer&gt; queue;</a:t>
+            </a:r>
+          </a:p>
+          <a:p>
+            <a:pPr>
+              <a:spcBef>
+                <a:spcPct val="0"/>
+              </a:spcBef>
+              <a:buFontTx/>
+              <a:buNone/>
+            </a:pPr>
+            <a:r>
+              <a:rPr lang="en-US" altLang="en-US" sz="2800" dirty="0">
+                <a:latin typeface="Tahoma" panose="020B0604030504040204" pitchFamily="34" charset="0"/>
+              </a:rPr>
+              <a:t>queue = new LinkedList&lt;Integer&gt;();</a:t>
+            </a:r>
+          </a:p>
+          <a:p>
+            <a:pPr>
+              <a:spcBef>
+                <a:spcPct val="0"/>
+              </a:spcBef>
+              <a:buFontTx/>
+              <a:buNone/>
+            </a:pPr>
+            <a:r>
+              <a:rPr lang="en-US" altLang="en-US" sz="2800" dirty="0" err="1">
+                <a:latin typeface="Tahoma" panose="020B0604030504040204" pitchFamily="34" charset="0"/>
+              </a:rPr>
+              <a:t>queue.</a:t>
+            </a:r>
+            <a:r>
+              <a:rPr lang="en-US" altLang="en-US" sz="2800" dirty="0" err="1">
+                <a:solidFill>
+                  <a:srgbClr val="0000FF"/>
+                </a:solidFill>
+                <a:latin typeface="Tahoma" panose="020B0604030504040204" pitchFamily="34" charset="0"/>
+              </a:rPr>
+              <a:t>add</a:t>
+            </a:r>
+            <a:r>
+              <a:rPr lang="en-US" altLang="en-US" sz="2800" dirty="0">
+                <a:solidFill>
+                  <a:srgbClr val="0000FF"/>
+                </a:solidFill>
+                <a:latin typeface="Tahoma" panose="020B0604030504040204" pitchFamily="34" charset="0"/>
+              </a:rPr>
+              <a:t>(11)</a:t>
+            </a:r>
+            <a:r>
+              <a:rPr lang="en-US" altLang="en-US" sz="2800" dirty="0">
+                <a:latin typeface="Tahoma" panose="020B0604030504040204" pitchFamily="34" charset="0"/>
+              </a:rPr>
+              <a:t>;</a:t>
+            </a:r>
+          </a:p>
+          <a:p>
+            <a:pPr>
+              <a:spcBef>
+                <a:spcPct val="0"/>
+              </a:spcBef>
+              <a:buFontTx/>
+              <a:buNone/>
+            </a:pPr>
+            <a:r>
+              <a:rPr lang="en-US" altLang="en-US" sz="2800" dirty="0" err="1">
+                <a:latin typeface="Tahoma" panose="020B0604030504040204" pitchFamily="34" charset="0"/>
+              </a:rPr>
+              <a:t>queue.</a:t>
+            </a:r>
+            <a:r>
+              <a:rPr lang="en-US" altLang="en-US" sz="2800" dirty="0" err="1">
+                <a:solidFill>
+                  <a:srgbClr val="0000FF"/>
+                </a:solidFill>
+                <a:latin typeface="Tahoma" panose="020B0604030504040204" pitchFamily="34" charset="0"/>
+              </a:rPr>
+              <a:t>add</a:t>
+            </a:r>
+            <a:r>
+              <a:rPr lang="en-US" altLang="en-US" sz="2800" dirty="0">
+                <a:solidFill>
+                  <a:srgbClr val="0000FF"/>
+                </a:solidFill>
+                <a:latin typeface="Tahoma" panose="020B0604030504040204" pitchFamily="34" charset="0"/>
+              </a:rPr>
+              <a:t>(7)</a:t>
+            </a:r>
+            <a:r>
+              <a:rPr lang="en-US" altLang="en-US" sz="2800" dirty="0">
+                <a:latin typeface="Tahoma" panose="020B0604030504040204" pitchFamily="34" charset="0"/>
+              </a:rPr>
+              <a:t>;</a:t>
+            </a:r>
+          </a:p>
+          <a:p>
+            <a:pPr>
+              <a:spcBef>
+                <a:spcPct val="0"/>
+              </a:spcBef>
+              <a:buFontTx/>
+              <a:buNone/>
+            </a:pPr>
+            <a:r>
+              <a:rPr lang="en-US" altLang="en-US" sz="2800" dirty="0" err="1">
+                <a:latin typeface="Tahoma" panose="020B0604030504040204" pitchFamily="34" charset="0"/>
+              </a:rPr>
+              <a:t>out.println</a:t>
+            </a:r>
+            <a:r>
+              <a:rPr lang="en-US" altLang="en-US" sz="2800" dirty="0">
+                <a:latin typeface="Tahoma" panose="020B0604030504040204" pitchFamily="34" charset="0"/>
+              </a:rPr>
+              <a:t>(queue);</a:t>
+            </a:r>
+          </a:p>
+          <a:p>
+            <a:pPr>
+              <a:spcBef>
+                <a:spcPct val="0"/>
+              </a:spcBef>
+              <a:buFontTx/>
+              <a:buNone/>
+            </a:pPr>
+            <a:r>
+              <a:rPr lang="en-US" altLang="en-US" sz="2800" dirty="0" err="1">
+                <a:latin typeface="Tahoma" panose="020B0604030504040204" pitchFamily="34" charset="0"/>
+              </a:rPr>
+              <a:t>out.println</a:t>
+            </a:r>
+            <a:r>
+              <a:rPr lang="en-US" altLang="en-US" sz="2800" dirty="0">
+                <a:latin typeface="Tahoma" panose="020B0604030504040204" pitchFamily="34" charset="0"/>
+              </a:rPr>
+              <a:t>(</a:t>
+            </a:r>
+            <a:r>
+              <a:rPr lang="en-US" altLang="en-US" sz="2800" dirty="0" err="1">
+                <a:latin typeface="Tahoma" panose="020B0604030504040204" pitchFamily="34" charset="0"/>
+              </a:rPr>
+              <a:t>queue.</a:t>
+            </a:r>
+            <a:r>
+              <a:rPr lang="en-US" altLang="en-US" sz="2800" dirty="0" err="1">
+                <a:solidFill>
+                  <a:srgbClr val="0000FF"/>
+                </a:solidFill>
+                <a:latin typeface="Tahoma" panose="020B0604030504040204" pitchFamily="34" charset="0"/>
+              </a:rPr>
+              <a:t>element</a:t>
+            </a:r>
+            <a:r>
+              <a:rPr lang="en-US" altLang="en-US" sz="2800" dirty="0">
+                <a:solidFill>
+                  <a:srgbClr val="0000FF"/>
+                </a:solidFill>
+                <a:latin typeface="Tahoma" panose="020B0604030504040204" pitchFamily="34" charset="0"/>
+              </a:rPr>
+              <a:t>()</a:t>
+            </a:r>
+            <a:r>
+              <a:rPr lang="en-US" altLang="en-US" sz="2800" dirty="0">
+                <a:latin typeface="Tahoma" panose="020B0604030504040204" pitchFamily="34" charset="0"/>
+              </a:rPr>
+              <a:t>);</a:t>
+            </a:r>
+          </a:p>
+          <a:p>
+            <a:pPr>
+              <a:spcBef>
+                <a:spcPct val="0"/>
+              </a:spcBef>
+              <a:buFontTx/>
+              <a:buNone/>
+            </a:pPr>
+            <a:r>
+              <a:rPr lang="en-US" altLang="en-US" sz="2800" dirty="0" err="1">
+                <a:latin typeface="Tahoma" panose="020B0604030504040204" pitchFamily="34" charset="0"/>
+              </a:rPr>
+              <a:t>queue.</a:t>
+            </a:r>
+            <a:r>
+              <a:rPr lang="en-US" altLang="en-US" sz="2800" dirty="0" err="1">
+                <a:solidFill>
+                  <a:srgbClr val="0000FF"/>
+                </a:solidFill>
+                <a:latin typeface="Tahoma" panose="020B0604030504040204" pitchFamily="34" charset="0"/>
+              </a:rPr>
+              <a:t>remove</a:t>
+            </a:r>
+            <a:r>
+              <a:rPr lang="en-US" altLang="en-US" sz="2800" dirty="0">
+                <a:solidFill>
+                  <a:srgbClr val="0000FF"/>
+                </a:solidFill>
+                <a:latin typeface="Tahoma" panose="020B0604030504040204" pitchFamily="34" charset="0"/>
+              </a:rPr>
+              <a:t>()</a:t>
+            </a:r>
+            <a:r>
+              <a:rPr lang="en-US" altLang="en-US" sz="2800" dirty="0">
+                <a:latin typeface="Tahoma" panose="020B0604030504040204" pitchFamily="34" charset="0"/>
+              </a:rPr>
+              <a:t>;</a:t>
+            </a:r>
+          </a:p>
+          <a:p>
+            <a:pPr>
+              <a:spcBef>
+                <a:spcPct val="0"/>
+              </a:spcBef>
+              <a:buFontTx/>
+              <a:buNone/>
+            </a:pPr>
+            <a:r>
+              <a:rPr lang="en-US" altLang="en-US" sz="2800" dirty="0" err="1">
+                <a:latin typeface="Tahoma" panose="020B0604030504040204" pitchFamily="34" charset="0"/>
+              </a:rPr>
+              <a:t>out.println</a:t>
+            </a:r>
+            <a:r>
+              <a:rPr lang="en-US" altLang="en-US" sz="2800" dirty="0">
+                <a:latin typeface="Tahoma" panose="020B0604030504040204" pitchFamily="34" charset="0"/>
+              </a:rPr>
+              <a:t>(</a:t>
+            </a:r>
+            <a:r>
+              <a:rPr lang="en-US" altLang="en-US" sz="2800" dirty="0" err="1">
+                <a:latin typeface="Tahoma" panose="020B0604030504040204" pitchFamily="34" charset="0"/>
+              </a:rPr>
+              <a:t>queue.</a:t>
+            </a:r>
+            <a:r>
+              <a:rPr lang="en-US" altLang="en-US" sz="2800" dirty="0" err="1">
+                <a:solidFill>
+                  <a:srgbClr val="0000FF"/>
+                </a:solidFill>
+                <a:latin typeface="Tahoma" panose="020B0604030504040204" pitchFamily="34" charset="0"/>
+              </a:rPr>
+              <a:t>element</a:t>
+            </a:r>
+            <a:r>
+              <a:rPr lang="en-US" altLang="en-US" sz="2800" dirty="0">
+                <a:solidFill>
+                  <a:srgbClr val="0000FF"/>
+                </a:solidFill>
+                <a:latin typeface="Tahoma" panose="020B0604030504040204" pitchFamily="34" charset="0"/>
+              </a:rPr>
+              <a:t>()</a:t>
+            </a:r>
+            <a:r>
+              <a:rPr lang="en-US" altLang="en-US" sz="2800" dirty="0">
+                <a:latin typeface="Tahoma" panose="020B0604030504040204" pitchFamily="34" charset="0"/>
+              </a:rPr>
+              <a:t>);</a:t>
+            </a:r>
+          </a:p>
+          <a:p>
+            <a:pPr>
+              <a:spcBef>
+                <a:spcPct val="0"/>
+              </a:spcBef>
+              <a:buFontTx/>
+              <a:buNone/>
+            </a:pPr>
+            <a:r>
+              <a:rPr lang="en-US" altLang="en-US" sz="2800" dirty="0" err="1">
+                <a:latin typeface="Tahoma" panose="020B0604030504040204" pitchFamily="34" charset="0"/>
+              </a:rPr>
+              <a:t>queue.</a:t>
+            </a:r>
+            <a:r>
+              <a:rPr lang="en-US" altLang="en-US" sz="2800" dirty="0" err="1">
+                <a:solidFill>
+                  <a:srgbClr val="0000FF"/>
+                </a:solidFill>
+                <a:latin typeface="Tahoma" panose="020B0604030504040204" pitchFamily="34" charset="0"/>
+              </a:rPr>
+              <a:t>remove</a:t>
+            </a:r>
+            <a:r>
+              <a:rPr lang="en-US" altLang="en-US" sz="2800" dirty="0">
+                <a:solidFill>
+                  <a:srgbClr val="0000FF"/>
+                </a:solidFill>
+                <a:latin typeface="Tahoma" panose="020B0604030504040204" pitchFamily="34" charset="0"/>
+              </a:rPr>
+              <a:t>()</a:t>
+            </a:r>
+            <a:r>
+              <a:rPr lang="en-US" altLang="en-US" sz="2800" dirty="0">
+                <a:latin typeface="Tahoma" panose="020B0604030504040204" pitchFamily="34" charset="0"/>
+              </a:rPr>
+              <a:t>;</a:t>
+            </a:r>
+          </a:p>
+          <a:p>
+            <a:pPr>
+              <a:spcBef>
+                <a:spcPct val="0"/>
+              </a:spcBef>
+              <a:buFontTx/>
+              <a:buNone/>
+            </a:pPr>
+            <a:r>
+              <a:rPr lang="en-US" altLang="en-US" sz="2800" dirty="0" err="1">
+                <a:latin typeface="Tahoma" panose="020B0604030504040204" pitchFamily="34" charset="0"/>
+              </a:rPr>
+              <a:t>out.println</a:t>
+            </a:r>
+            <a:r>
+              <a:rPr lang="en-US" altLang="en-US" sz="2800" dirty="0">
+                <a:latin typeface="Tahoma" panose="020B0604030504040204" pitchFamily="34" charset="0"/>
+              </a:rPr>
+              <a:t>(queue);</a:t>
+            </a:r>
+          </a:p>
+          <a:p>
+            <a:pPr>
+              <a:spcBef>
+                <a:spcPct val="0"/>
+              </a:spcBef>
+              <a:buFontTx/>
+              <a:buNone/>
+            </a:pPr>
+            <a:endParaRPr lang="en-US" altLang="en-US" sz="2800" dirty="0">
+              <a:latin typeface="Tahoma" panose="020B0604030504040204" pitchFamily="34" charset="0"/>
+            </a:endParaRPr>
+          </a:p>
+        </p:txBody>
+      </p:sp>
+      <p:sp>
+        <p:nvSpPr>
+          <p:cNvPr id="20485" name="Text Box 4">
+            <a:extLst>
+              <a:ext uri="{FF2B5EF4-FFF2-40B4-BE49-F238E27FC236}">
+                <a16:creationId xmlns:a16="http://schemas.microsoft.com/office/drawing/2014/main" id="{3AFAB5FD-4374-4D4F-972E-A0AA7FE62F3D}"/>
+              </a:ext>
+            </a:extLst>
+          </p:cNvPr>
+          <p:cNvSpPr txBox="1">
+            <a:spLocks noChangeArrowheads="1"/>
+          </p:cNvSpPr>
+          <p:nvPr/>
+        </p:nvSpPr>
+        <p:spPr bwMode="auto">
+          <a:xfrm>
+            <a:off x="6934200" y="3200400"/>
+            <a:ext cx="1905000" cy="2300288"/>
+          </a:xfrm>
+          <a:prstGeom prst="rect">
+            <a:avLst/>
+          </a:prstGeom>
+          <a:noFill/>
+          <a:ln w="12700">
+            <a:solidFill>
+              <a:srgbClr val="993300"/>
+            </a:solidFill>
+            <a:miter lim="800000"/>
+            <a:headEnd type="none" w="sm" len="sm"/>
+            <a:tailEnd type="none" w="sm" len="sm"/>
+          </a:ln>
+          <a:effectLst/>
+          <a:extLst>
+            <a:ext uri="{909E8E84-426E-40DD-AFC4-6F175D3DCCD1}">
+              <a14:hiddenFill xmlns:a14="http://schemas.microsoft.com/office/drawing/2010/main">
+                <a:solidFill>
+                  <a:schemeClr val="accent1"/>
+                </a:solidFill>
+              </a14:hiddenFill>
+            </a:ext>
+            <a:ext uri="{AF507438-7753-43E0-B8FC-AC1667EBCBE1}">
+              <a14:hiddenEffects xmlns:a14="http://schemas.microsoft.com/office/drawing/2010/main">
+                <a:effectLst>
+                  <a:outerShdw dist="35921" dir="2700000" algn="ctr" rotWithShape="0">
+                    <a:schemeClr val="bg2"/>
+                  </a:outerShdw>
+                </a:effectLst>
+              </a14:hiddenEffects>
+            </a:ext>
+          </a:extLst>
+        </p:spPr>
+        <p:txBody>
+          <a:bodyPr>
+            <a:spAutoFit/>
+          </a:bodyPr>
+          <a:lstStyle>
+            <a:lvl1pPr>
+              <a:spcBef>
+                <a:spcPct val="20000"/>
+              </a:spcBef>
+              <a:buChar char="•"/>
+              <a:defRPr sz="3200">
+                <a:solidFill>
+                  <a:schemeClr val="tx1"/>
+                </a:solidFill>
+                <a:latin typeface="Times New Roman" panose="02020603050405020304" pitchFamily="18" charset="0"/>
+              </a:defRPr>
+            </a:lvl1pPr>
+            <a:lvl2pPr marL="742950" indent="-285750">
+              <a:spcBef>
+                <a:spcPct val="20000"/>
+              </a:spcBef>
+              <a:buChar char="–"/>
+              <a:defRPr sz="2800">
+                <a:solidFill>
+                  <a:schemeClr val="tx1"/>
+                </a:solidFill>
+                <a:latin typeface="Times New Roman" panose="02020603050405020304" pitchFamily="18" charset="0"/>
+              </a:defRPr>
+            </a:lvl2pPr>
+            <a:lvl3pPr marL="1143000" indent="-228600">
+              <a:spcBef>
+                <a:spcPct val="20000"/>
+              </a:spcBef>
+              <a:buChar char="•"/>
+              <a:defRPr sz="2400">
+                <a:solidFill>
+                  <a:schemeClr val="tx1"/>
+                </a:solidFill>
+                <a:latin typeface="Times New Roman" panose="02020603050405020304" pitchFamily="18" charset="0"/>
+              </a:defRPr>
+            </a:lvl3pPr>
+            <a:lvl4pPr marL="1600200" indent="-228600">
+              <a:spcBef>
+                <a:spcPct val="20000"/>
+              </a:spcBef>
+              <a:buChar char="–"/>
+              <a:defRPr sz="2000">
+                <a:solidFill>
+                  <a:schemeClr val="tx1"/>
+                </a:solidFill>
+                <a:latin typeface="Times New Roman" panose="02020603050405020304" pitchFamily="18" charset="0"/>
+              </a:defRPr>
+            </a:lvl4pPr>
+            <a:lvl5pPr marL="2057400" indent="-228600">
+              <a:spcBef>
+                <a:spcPct val="20000"/>
+              </a:spcBef>
+              <a:buChar char="»"/>
+              <a:defRPr sz="2000">
+                <a:solidFill>
+                  <a:schemeClr val="tx1"/>
+                </a:solidFill>
+                <a:latin typeface="Times New Roman" panose="02020603050405020304" pitchFamily="18" charset="0"/>
+              </a:defRPr>
+            </a:lvl5pPr>
+            <a:lvl6pPr marL="2514600" indent="-228600" eaLnBrk="0" fontAlgn="base" hangingPunct="0">
+              <a:spcBef>
+                <a:spcPct val="20000"/>
+              </a:spcBef>
+              <a:spcAft>
+                <a:spcPct val="0"/>
+              </a:spcAft>
+              <a:buChar char="»"/>
+              <a:defRPr sz="2000">
+                <a:solidFill>
+                  <a:schemeClr val="tx1"/>
+                </a:solidFill>
+                <a:latin typeface="Times New Roman" panose="02020603050405020304" pitchFamily="18" charset="0"/>
+              </a:defRPr>
+            </a:lvl6pPr>
+            <a:lvl7pPr marL="2971800" indent="-228600" eaLnBrk="0" fontAlgn="base" hangingPunct="0">
+              <a:spcBef>
+                <a:spcPct val="20000"/>
+              </a:spcBef>
+              <a:spcAft>
+                <a:spcPct val="0"/>
+              </a:spcAft>
+              <a:buChar char="»"/>
+              <a:defRPr sz="2000">
+                <a:solidFill>
+                  <a:schemeClr val="tx1"/>
+                </a:solidFill>
+                <a:latin typeface="Times New Roman" panose="02020603050405020304" pitchFamily="18" charset="0"/>
+              </a:defRPr>
+            </a:lvl7pPr>
+            <a:lvl8pPr marL="3429000" indent="-228600" eaLnBrk="0" fontAlgn="base" hangingPunct="0">
+              <a:spcBef>
+                <a:spcPct val="20000"/>
+              </a:spcBef>
+              <a:spcAft>
+                <a:spcPct val="0"/>
+              </a:spcAft>
+              <a:buChar char="»"/>
+              <a:defRPr sz="2000">
+                <a:solidFill>
+                  <a:schemeClr val="tx1"/>
+                </a:solidFill>
+                <a:latin typeface="Times New Roman" panose="02020603050405020304" pitchFamily="18" charset="0"/>
+              </a:defRPr>
+            </a:lvl8pPr>
+            <a:lvl9pPr marL="3886200" indent="-228600" eaLnBrk="0" fontAlgn="base" hangingPunct="0">
+              <a:spcBef>
+                <a:spcPct val="20000"/>
+              </a:spcBef>
+              <a:spcAft>
+                <a:spcPct val="0"/>
+              </a:spcAft>
+              <a:buChar char="»"/>
+              <a:defRPr sz="2000">
+                <a:solidFill>
+                  <a:schemeClr val="tx1"/>
+                </a:solidFill>
+                <a:latin typeface="Times New Roman" panose="02020603050405020304" pitchFamily="18" charset="0"/>
+              </a:defRPr>
+            </a:lvl9pPr>
+          </a:lstStyle>
+          <a:p>
+            <a:pPr>
+              <a:spcBef>
+                <a:spcPct val="50000"/>
+              </a:spcBef>
+              <a:buFontTx/>
+              <a:buNone/>
+            </a:pPr>
+            <a:r>
+              <a:rPr lang="en-US" altLang="en-US" u="sng">
+                <a:solidFill>
+                  <a:srgbClr val="FF0000"/>
+                </a:solidFill>
+                <a:latin typeface="Tahoma" panose="020B0604030504040204" pitchFamily="34" charset="0"/>
+              </a:rPr>
+              <a:t>OUTPUT</a:t>
+            </a:r>
+          </a:p>
+          <a:p>
+            <a:pPr>
+              <a:spcBef>
+                <a:spcPct val="0"/>
+              </a:spcBef>
+              <a:buFontTx/>
+              <a:buNone/>
+            </a:pPr>
+            <a:r>
+              <a:rPr lang="en-US" altLang="en-US" sz="2800">
+                <a:latin typeface="Tahoma" panose="020B0604030504040204" pitchFamily="34" charset="0"/>
+              </a:rPr>
+              <a:t>[11, 7]</a:t>
+            </a:r>
+          </a:p>
+          <a:p>
+            <a:pPr>
+              <a:spcBef>
+                <a:spcPct val="0"/>
+              </a:spcBef>
+              <a:buFontTx/>
+              <a:buNone/>
+            </a:pPr>
+            <a:r>
+              <a:rPr lang="en-US" altLang="en-US" sz="2800">
+                <a:latin typeface="Tahoma" panose="020B0604030504040204" pitchFamily="34" charset="0"/>
+              </a:rPr>
+              <a:t>11</a:t>
+            </a:r>
+          </a:p>
+          <a:p>
+            <a:pPr>
+              <a:spcBef>
+                <a:spcPct val="0"/>
+              </a:spcBef>
+              <a:buFontTx/>
+              <a:buNone/>
+            </a:pPr>
+            <a:r>
+              <a:rPr lang="en-US" altLang="en-US" sz="2800">
+                <a:latin typeface="Tahoma" panose="020B0604030504040204" pitchFamily="34" charset="0"/>
+              </a:rPr>
+              <a:t>7</a:t>
+            </a:r>
+          </a:p>
+          <a:p>
+            <a:pPr>
+              <a:spcBef>
+                <a:spcPct val="0"/>
+              </a:spcBef>
+              <a:buFontTx/>
+              <a:buNone/>
+            </a:pPr>
+            <a:r>
+              <a:rPr lang="en-US" altLang="en-US" sz="2800">
+                <a:latin typeface="Tahoma" panose="020B0604030504040204" pitchFamily="34" charset="0"/>
+              </a:rPr>
+              <a:t>[]</a:t>
+            </a:r>
+          </a:p>
+        </p:txBody>
+      </p:sp>
+      <p:sp>
+        <p:nvSpPr>
+          <p:cNvPr id="2" name="Rectangle 1">
+            <a:extLst>
+              <a:ext uri="{FF2B5EF4-FFF2-40B4-BE49-F238E27FC236}">
+                <a16:creationId xmlns:a16="http://schemas.microsoft.com/office/drawing/2014/main" id="{D188A6B1-6D0E-8642-F073-B997658C1205}"/>
+              </a:ext>
+            </a:extLst>
+          </p:cNvPr>
+          <p:cNvSpPr/>
+          <p:nvPr/>
+        </p:nvSpPr>
+        <p:spPr>
+          <a:xfrm>
+            <a:off x="622300" y="338435"/>
+            <a:ext cx="8039380" cy="923330"/>
+          </a:xfrm>
+          <a:prstGeom prst="rect">
+            <a:avLst/>
+          </a:prstGeom>
+          <a:noFill/>
+        </p:spPr>
+        <p:txBody>
+          <a:bodyPr wrap="none" lIns="91440" tIns="45720" rIns="91440" bIns="45720">
+            <a:spAutoFit/>
+          </a:bodyPr>
+          <a:lstStyle/>
+          <a:p>
+            <a:pPr algn="ctr"/>
+            <a:r>
+              <a:rPr lang="en-US" sz="5400" b="1" cap="none" spc="0" dirty="0">
+                <a:ln w="12700" cmpd="sng">
+                  <a:solidFill>
+                    <a:schemeClr val="accent4"/>
+                  </a:solidFill>
+                  <a:prstDash val="solid"/>
+                </a:ln>
+                <a:gradFill>
+                  <a:gsLst>
+                    <a:gs pos="0">
+                      <a:schemeClr val="accent4"/>
+                    </a:gs>
+                    <a:gs pos="4000">
+                      <a:schemeClr val="accent4">
+                        <a:lumMod val="60000"/>
+                        <a:lumOff val="40000"/>
+                      </a:schemeClr>
+                    </a:gs>
+                    <a:gs pos="87000">
+                      <a:schemeClr val="accent4">
+                        <a:lumMod val="20000"/>
+                        <a:lumOff val="80000"/>
+                      </a:schemeClr>
+                    </a:gs>
+                  </a:gsLst>
+                  <a:lin ang="5400000"/>
+                </a:gradFill>
+                <a:effectLst/>
+              </a:rPr>
+              <a:t>Add, Remove, Element</a:t>
+            </a:r>
+          </a:p>
+        </p:txBody>
+      </p:sp>
+    </p:spTree>
+    <p:extLst>
+      <p:ext uri="{BB962C8B-B14F-4D97-AF65-F5344CB8AC3E}">
+        <p14:creationId xmlns:p14="http://schemas.microsoft.com/office/powerpoint/2010/main" val="488571070"/>
+      </p:ext>
+    </p:extLst>
+  </p:cSld>
+  <p:clrMapOvr>
+    <a:masterClrMapping/>
+  </p:clrMapOvr>
+</p:sld>
+</file>
+
+<file path=ppt/slides/slide29.xml><?xml version="1.0" encoding="utf-8"?>
+<p:sld xmlns:a="http://schemas.openxmlformats.org/drawingml/2006/main" xmlns:r="http://schemas.openxmlformats.org/officeDocument/2006/relationships" xmlns:p="http://schemas.openxmlformats.org/presentationml/2006/main">
+  <p:cSld>
+    <p:spTree>
+      <p:nvGrpSpPr>
+        <p:cNvPr id="1" name=""/>
+        <p:cNvGrpSpPr/>
+        <p:nvPr/>
+      </p:nvGrpSpPr>
+      <p:grpSpPr>
+        <a:xfrm>
+          <a:off x="0" y="0"/>
+          <a:ext cx="0" cy="0"/>
+          <a:chOff x="0" y="0"/>
+          <a:chExt cx="0" cy="0"/>
+        </a:xfrm>
+      </p:grpSpPr>
+      <p:sp>
+        <p:nvSpPr>
+          <p:cNvPr id="20482" name="Footer Placeholder 3">
+            <a:extLst>
+              <a:ext uri="{FF2B5EF4-FFF2-40B4-BE49-F238E27FC236}">
+                <a16:creationId xmlns:a16="http://schemas.microsoft.com/office/drawing/2014/main" id="{190EA73F-91E8-4AA5-A9E9-87D31767202B}"/>
+              </a:ext>
+            </a:extLst>
+          </p:cNvPr>
+          <p:cNvSpPr>
+            <a:spLocks noGrp="1"/>
+          </p:cNvSpPr>
+          <p:nvPr>
+            <p:ph type="ftr" sz="quarter" idx="12"/>
+          </p:nvPr>
+        </p:nvSpPr>
+        <p:spPr>
+          <a:noFill/>
+        </p:spPr>
+        <p:txBody>
+          <a:bodyPr/>
+          <a:lstStyle>
+            <a:lvl1pPr>
+              <a:spcBef>
+                <a:spcPct val="20000"/>
+              </a:spcBef>
+              <a:buChar char="•"/>
+              <a:defRPr sz="3200">
+                <a:solidFill>
+                  <a:schemeClr val="tx1"/>
+                </a:solidFill>
+                <a:latin typeface="Times New Roman" panose="02020603050405020304" pitchFamily="18" charset="0"/>
+              </a:defRPr>
+            </a:lvl1pPr>
+            <a:lvl2pPr marL="742950" indent="-285750">
+              <a:spcBef>
+                <a:spcPct val="20000"/>
+              </a:spcBef>
+              <a:buChar char="–"/>
+              <a:defRPr sz="2800">
+                <a:solidFill>
+                  <a:schemeClr val="tx1"/>
+                </a:solidFill>
+                <a:latin typeface="Times New Roman" panose="02020603050405020304" pitchFamily="18" charset="0"/>
+              </a:defRPr>
+            </a:lvl2pPr>
+            <a:lvl3pPr marL="1143000" indent="-228600">
+              <a:spcBef>
+                <a:spcPct val="20000"/>
+              </a:spcBef>
+              <a:buChar char="•"/>
+              <a:defRPr sz="2400">
+                <a:solidFill>
+                  <a:schemeClr val="tx1"/>
+                </a:solidFill>
+                <a:latin typeface="Times New Roman" panose="02020603050405020304" pitchFamily="18" charset="0"/>
+              </a:defRPr>
+            </a:lvl3pPr>
+            <a:lvl4pPr marL="1600200" indent="-228600">
+              <a:spcBef>
+                <a:spcPct val="20000"/>
+              </a:spcBef>
+              <a:buChar char="–"/>
+              <a:defRPr sz="2000">
+                <a:solidFill>
+                  <a:schemeClr val="tx1"/>
+                </a:solidFill>
+                <a:latin typeface="Times New Roman" panose="02020603050405020304" pitchFamily="18" charset="0"/>
+              </a:defRPr>
+            </a:lvl4pPr>
+            <a:lvl5pPr marL="2057400" indent="-228600">
+              <a:spcBef>
+                <a:spcPct val="20000"/>
+              </a:spcBef>
+              <a:buChar char="»"/>
+              <a:defRPr sz="2000">
+                <a:solidFill>
+                  <a:schemeClr val="tx1"/>
+                </a:solidFill>
+                <a:latin typeface="Times New Roman" panose="02020603050405020304" pitchFamily="18" charset="0"/>
+              </a:defRPr>
+            </a:lvl5pPr>
+            <a:lvl6pPr marL="2514600" indent="-228600" eaLnBrk="0" fontAlgn="base" hangingPunct="0">
+              <a:spcBef>
+                <a:spcPct val="20000"/>
+              </a:spcBef>
+              <a:spcAft>
+                <a:spcPct val="0"/>
+              </a:spcAft>
+              <a:buChar char="»"/>
+              <a:defRPr sz="2000">
+                <a:solidFill>
+                  <a:schemeClr val="tx1"/>
+                </a:solidFill>
+                <a:latin typeface="Times New Roman" panose="02020603050405020304" pitchFamily="18" charset="0"/>
+              </a:defRPr>
+            </a:lvl6pPr>
+            <a:lvl7pPr marL="2971800" indent="-228600" eaLnBrk="0" fontAlgn="base" hangingPunct="0">
+              <a:spcBef>
+                <a:spcPct val="20000"/>
+              </a:spcBef>
+              <a:spcAft>
+                <a:spcPct val="0"/>
+              </a:spcAft>
+              <a:buChar char="»"/>
+              <a:defRPr sz="2000">
+                <a:solidFill>
+                  <a:schemeClr val="tx1"/>
+                </a:solidFill>
+                <a:latin typeface="Times New Roman" panose="02020603050405020304" pitchFamily="18" charset="0"/>
+              </a:defRPr>
+            </a:lvl7pPr>
+            <a:lvl8pPr marL="3429000" indent="-228600" eaLnBrk="0" fontAlgn="base" hangingPunct="0">
+              <a:spcBef>
+                <a:spcPct val="20000"/>
+              </a:spcBef>
+              <a:spcAft>
+                <a:spcPct val="0"/>
+              </a:spcAft>
+              <a:buChar char="»"/>
+              <a:defRPr sz="2000">
+                <a:solidFill>
+                  <a:schemeClr val="tx1"/>
+                </a:solidFill>
+                <a:latin typeface="Times New Roman" panose="02020603050405020304" pitchFamily="18" charset="0"/>
+              </a:defRPr>
+            </a:lvl8pPr>
+            <a:lvl9pPr marL="3886200" indent="-228600" eaLnBrk="0" fontAlgn="base" hangingPunct="0">
+              <a:spcBef>
+                <a:spcPct val="20000"/>
+              </a:spcBef>
+              <a:spcAft>
+                <a:spcPct val="0"/>
+              </a:spcAft>
+              <a:buChar char="»"/>
+              <a:defRPr sz="2000">
+                <a:solidFill>
+                  <a:schemeClr val="tx1"/>
+                </a:solidFill>
+                <a:latin typeface="Times New Roman" panose="02020603050405020304" pitchFamily="18" charset="0"/>
+              </a:defRPr>
+            </a:lvl9pPr>
+          </a:lstStyle>
+          <a:p>
+            <a:pPr>
+              <a:spcBef>
+                <a:spcPct val="0"/>
+              </a:spcBef>
+              <a:buFontTx/>
+              <a:buNone/>
+            </a:pPr>
+            <a:endParaRPr lang="en-US" altLang="en-US" sz="800" b="1"/>
+          </a:p>
+          <a:p>
+            <a:pPr>
+              <a:spcBef>
+                <a:spcPct val="0"/>
+              </a:spcBef>
+              <a:buFontTx/>
+              <a:buNone/>
+            </a:pPr>
+            <a:endParaRPr lang="en-US" altLang="en-US" sz="800">
+              <a:latin typeface="Tahoma" panose="020B0604030504040204" pitchFamily="34" charset="0"/>
+            </a:endParaRPr>
+          </a:p>
+          <a:p>
+            <a:pPr>
+              <a:spcBef>
+                <a:spcPct val="0"/>
+              </a:spcBef>
+              <a:buFontTx/>
+              <a:buNone/>
+            </a:pPr>
+            <a:endParaRPr lang="en-US" altLang="en-US" sz="800" b="1">
+              <a:latin typeface="Tahoma" panose="020B0604030504040204" pitchFamily="34" charset="0"/>
+            </a:endParaRPr>
+          </a:p>
+          <a:p>
+            <a:pPr>
+              <a:spcBef>
+                <a:spcPct val="0"/>
+              </a:spcBef>
+              <a:buFontTx/>
+              <a:buNone/>
+            </a:pPr>
+            <a:r>
+              <a:rPr lang="en-US" altLang="en-US" sz="800" b="1">
+                <a:latin typeface="Tahoma" panose="020B0604030504040204" pitchFamily="34" charset="0"/>
+              </a:rPr>
+              <a:t>© A+ Computer Science  -  www.apluscompsci.com</a:t>
+            </a:r>
+          </a:p>
+        </p:txBody>
+      </p:sp>
+      <p:sp>
+        <p:nvSpPr>
+          <p:cNvPr id="20483" name="Text Box 2">
+            <a:extLst>
+              <a:ext uri="{FF2B5EF4-FFF2-40B4-BE49-F238E27FC236}">
+                <a16:creationId xmlns:a16="http://schemas.microsoft.com/office/drawing/2014/main" id="{4798B9E7-9EED-415C-92F1-0A91537E0036}"/>
+              </a:ext>
+            </a:extLst>
+          </p:cNvPr>
+          <p:cNvSpPr txBox="1">
+            <a:spLocks noChangeArrowheads="1"/>
+          </p:cNvSpPr>
+          <p:nvPr/>
+        </p:nvSpPr>
+        <p:spPr bwMode="auto">
+          <a:xfrm>
+            <a:off x="609600" y="1600200"/>
+            <a:ext cx="7010400" cy="4789488"/>
+          </a:xfrm>
+          <a:prstGeom prst="rect">
+            <a:avLst/>
+          </a:prstGeom>
+          <a:noFill/>
+          <a:ln>
+            <a:noFill/>
+          </a:ln>
+          <a:effectLst/>
+          <a:extLst>
+            <a:ext uri="{909E8E84-426E-40DD-AFC4-6F175D3DCCD1}">
+              <a14:hiddenFill xmlns:a14="http://schemas.microsoft.com/office/drawing/2010/main">
+                <a:solidFill>
+                  <a:schemeClr val="accent1"/>
+                </a:solidFill>
+              </a14:hiddenFill>
+            </a:ext>
+            <a:ext uri="{91240B29-F687-4F45-9708-019B960494DF}">
+              <a14:hiddenLine xmlns:a14="http://schemas.microsoft.com/office/drawing/2010/main" w="9525">
+                <a:solidFill>
+                  <a:schemeClr val="tx1"/>
+                </a:solidFill>
+                <a:miter lim="800000"/>
+                <a:headEnd/>
+                <a:tailEnd/>
+              </a14:hiddenLine>
+            </a:ext>
+            <a:ext uri="{AF507438-7753-43E0-B8FC-AC1667EBCBE1}">
+              <a14:hiddenEffects xmlns:a14="http://schemas.microsoft.com/office/drawing/2010/main">
+                <a:effectLst>
+                  <a:outerShdw dist="35921" dir="2700000" algn="ctr" rotWithShape="0">
+                    <a:schemeClr val="bg2"/>
+                  </a:outerShdw>
+                </a:effectLst>
+              </a14:hiddenEffects>
+            </a:ext>
+          </a:extLst>
+        </p:spPr>
+        <p:txBody>
+          <a:bodyPr>
+            <a:spAutoFit/>
+          </a:bodyPr>
+          <a:lstStyle>
+            <a:lvl1pPr>
+              <a:spcBef>
+                <a:spcPct val="20000"/>
+              </a:spcBef>
+              <a:buChar char="•"/>
+              <a:defRPr sz="3200">
+                <a:solidFill>
+                  <a:schemeClr val="tx1"/>
+                </a:solidFill>
+                <a:latin typeface="Times New Roman" panose="02020603050405020304" pitchFamily="18" charset="0"/>
+              </a:defRPr>
+            </a:lvl1pPr>
+            <a:lvl2pPr marL="742950" indent="-285750">
+              <a:spcBef>
+                <a:spcPct val="20000"/>
+              </a:spcBef>
+              <a:buChar char="–"/>
+              <a:defRPr sz="2800">
+                <a:solidFill>
+                  <a:schemeClr val="tx1"/>
+                </a:solidFill>
+                <a:latin typeface="Times New Roman" panose="02020603050405020304" pitchFamily="18" charset="0"/>
+              </a:defRPr>
+            </a:lvl2pPr>
+            <a:lvl3pPr marL="1143000" indent="-228600">
+              <a:spcBef>
+                <a:spcPct val="20000"/>
+              </a:spcBef>
+              <a:buChar char="•"/>
+              <a:defRPr sz="2400">
+                <a:solidFill>
+                  <a:schemeClr val="tx1"/>
+                </a:solidFill>
+                <a:latin typeface="Times New Roman" panose="02020603050405020304" pitchFamily="18" charset="0"/>
+              </a:defRPr>
+            </a:lvl3pPr>
+            <a:lvl4pPr marL="1600200" indent="-228600">
+              <a:spcBef>
+                <a:spcPct val="20000"/>
+              </a:spcBef>
+              <a:buChar char="–"/>
+              <a:defRPr sz="2000">
+                <a:solidFill>
+                  <a:schemeClr val="tx1"/>
+                </a:solidFill>
+                <a:latin typeface="Times New Roman" panose="02020603050405020304" pitchFamily="18" charset="0"/>
+              </a:defRPr>
+            </a:lvl4pPr>
+            <a:lvl5pPr marL="2057400" indent="-228600">
+              <a:spcBef>
+                <a:spcPct val="20000"/>
+              </a:spcBef>
+              <a:buChar char="»"/>
+              <a:defRPr sz="2000">
+                <a:solidFill>
+                  <a:schemeClr val="tx1"/>
+                </a:solidFill>
+                <a:latin typeface="Times New Roman" panose="02020603050405020304" pitchFamily="18" charset="0"/>
+              </a:defRPr>
+            </a:lvl5pPr>
+            <a:lvl6pPr marL="2514600" indent="-228600" eaLnBrk="0" fontAlgn="base" hangingPunct="0">
+              <a:spcBef>
+                <a:spcPct val="20000"/>
+              </a:spcBef>
+              <a:spcAft>
+                <a:spcPct val="0"/>
+              </a:spcAft>
+              <a:buChar char="»"/>
+              <a:defRPr sz="2000">
+                <a:solidFill>
+                  <a:schemeClr val="tx1"/>
+                </a:solidFill>
+                <a:latin typeface="Times New Roman" panose="02020603050405020304" pitchFamily="18" charset="0"/>
+              </a:defRPr>
+            </a:lvl6pPr>
+            <a:lvl7pPr marL="2971800" indent="-228600" eaLnBrk="0" fontAlgn="base" hangingPunct="0">
+              <a:spcBef>
+                <a:spcPct val="20000"/>
+              </a:spcBef>
+              <a:spcAft>
+                <a:spcPct val="0"/>
+              </a:spcAft>
+              <a:buChar char="»"/>
+              <a:defRPr sz="2000">
+                <a:solidFill>
+                  <a:schemeClr val="tx1"/>
+                </a:solidFill>
+                <a:latin typeface="Times New Roman" panose="02020603050405020304" pitchFamily="18" charset="0"/>
+              </a:defRPr>
+            </a:lvl7pPr>
+            <a:lvl8pPr marL="3429000" indent="-228600" eaLnBrk="0" fontAlgn="base" hangingPunct="0">
+              <a:spcBef>
+                <a:spcPct val="20000"/>
+              </a:spcBef>
+              <a:spcAft>
+                <a:spcPct val="0"/>
+              </a:spcAft>
+              <a:buChar char="»"/>
+              <a:defRPr sz="2000">
+                <a:solidFill>
+                  <a:schemeClr val="tx1"/>
+                </a:solidFill>
+                <a:latin typeface="Times New Roman" panose="02020603050405020304" pitchFamily="18" charset="0"/>
+              </a:defRPr>
+            </a:lvl8pPr>
+            <a:lvl9pPr marL="3886200" indent="-228600" eaLnBrk="0" fontAlgn="base" hangingPunct="0">
+              <a:spcBef>
+                <a:spcPct val="20000"/>
+              </a:spcBef>
+              <a:spcAft>
+                <a:spcPct val="0"/>
+              </a:spcAft>
+              <a:buChar char="»"/>
+              <a:defRPr sz="2000">
+                <a:solidFill>
+                  <a:schemeClr val="tx1"/>
+                </a:solidFill>
+                <a:latin typeface="Times New Roman" panose="02020603050405020304" pitchFamily="18" charset="0"/>
+              </a:defRPr>
+            </a:lvl9pPr>
+          </a:lstStyle>
+          <a:p>
+            <a:pPr>
+              <a:spcBef>
+                <a:spcPct val="0"/>
+              </a:spcBef>
+              <a:buFontTx/>
+              <a:buNone/>
+            </a:pPr>
+            <a:r>
+              <a:rPr lang="en-US" altLang="en-US" sz="2800" dirty="0">
+                <a:latin typeface="Tahoma" panose="020B0604030504040204" pitchFamily="34" charset="0"/>
+              </a:rPr>
+              <a:t>Queue&lt;Integer&gt; queue;</a:t>
+            </a:r>
+          </a:p>
+          <a:p>
+            <a:pPr>
+              <a:spcBef>
+                <a:spcPct val="0"/>
+              </a:spcBef>
+              <a:buFontTx/>
+              <a:buNone/>
+            </a:pPr>
+            <a:r>
+              <a:rPr lang="en-US" altLang="en-US" sz="2800" dirty="0">
+                <a:latin typeface="Tahoma" panose="020B0604030504040204" pitchFamily="34" charset="0"/>
+              </a:rPr>
+              <a:t>queue = new LinkedList&lt;Integer&gt;();</a:t>
+            </a:r>
+          </a:p>
+          <a:p>
+            <a:pPr>
+              <a:spcBef>
+                <a:spcPct val="0"/>
+              </a:spcBef>
+              <a:buFontTx/>
+              <a:buNone/>
+            </a:pPr>
+            <a:r>
+              <a:rPr lang="en-US" altLang="en-US" sz="2800" dirty="0" err="1">
+                <a:latin typeface="Tahoma" panose="020B0604030504040204" pitchFamily="34" charset="0"/>
+              </a:rPr>
+              <a:t>queue.</a:t>
+            </a:r>
+            <a:r>
+              <a:rPr lang="en-US" altLang="en-US" sz="2800" dirty="0" err="1">
+                <a:solidFill>
+                  <a:srgbClr val="7030A0"/>
+                </a:solidFill>
+                <a:latin typeface="Tahoma" panose="020B0604030504040204" pitchFamily="34" charset="0"/>
+              </a:rPr>
+              <a:t>offer</a:t>
+            </a:r>
+            <a:r>
+              <a:rPr lang="en-US" altLang="en-US" sz="2800" dirty="0">
+                <a:solidFill>
+                  <a:srgbClr val="7030A0"/>
+                </a:solidFill>
+                <a:latin typeface="Tahoma" panose="020B0604030504040204" pitchFamily="34" charset="0"/>
+              </a:rPr>
+              <a:t>(11)</a:t>
+            </a:r>
+            <a:r>
+              <a:rPr lang="en-US" altLang="en-US" sz="2800" dirty="0">
+                <a:latin typeface="Tahoma" panose="020B0604030504040204" pitchFamily="34" charset="0"/>
+              </a:rPr>
+              <a:t>;</a:t>
+            </a:r>
+          </a:p>
+          <a:p>
+            <a:pPr>
+              <a:spcBef>
+                <a:spcPct val="0"/>
+              </a:spcBef>
+              <a:buFontTx/>
+              <a:buNone/>
+            </a:pPr>
+            <a:r>
+              <a:rPr lang="en-US" altLang="en-US" sz="2800" dirty="0" err="1">
+                <a:latin typeface="Tahoma" panose="020B0604030504040204" pitchFamily="34" charset="0"/>
+              </a:rPr>
+              <a:t>queue.</a:t>
+            </a:r>
+            <a:r>
+              <a:rPr lang="en-US" altLang="en-US" sz="2800" dirty="0" err="1">
+                <a:solidFill>
+                  <a:srgbClr val="7030A0"/>
+                </a:solidFill>
+                <a:latin typeface="Tahoma" panose="020B0604030504040204" pitchFamily="34" charset="0"/>
+              </a:rPr>
+              <a:t>offer</a:t>
+            </a:r>
+            <a:r>
+              <a:rPr lang="en-US" altLang="en-US" sz="2800" dirty="0">
+                <a:solidFill>
+                  <a:srgbClr val="7030A0"/>
+                </a:solidFill>
+                <a:latin typeface="Tahoma" panose="020B0604030504040204" pitchFamily="34" charset="0"/>
+              </a:rPr>
+              <a:t>(7)</a:t>
+            </a:r>
+            <a:r>
+              <a:rPr lang="en-US" altLang="en-US" sz="2800" dirty="0">
+                <a:latin typeface="Tahoma" panose="020B0604030504040204" pitchFamily="34" charset="0"/>
+              </a:rPr>
+              <a:t>;</a:t>
+            </a:r>
+          </a:p>
+          <a:p>
+            <a:pPr>
+              <a:spcBef>
+                <a:spcPct val="0"/>
+              </a:spcBef>
+              <a:buFontTx/>
+              <a:buNone/>
+            </a:pPr>
+            <a:r>
+              <a:rPr lang="en-US" altLang="en-US" sz="2800" dirty="0" err="1">
+                <a:latin typeface="Tahoma" panose="020B0604030504040204" pitchFamily="34" charset="0"/>
+              </a:rPr>
+              <a:t>out.println</a:t>
+            </a:r>
+            <a:r>
+              <a:rPr lang="en-US" altLang="en-US" sz="2800" dirty="0">
+                <a:latin typeface="Tahoma" panose="020B0604030504040204" pitchFamily="34" charset="0"/>
+              </a:rPr>
+              <a:t>(queue);</a:t>
+            </a:r>
+          </a:p>
+          <a:p>
+            <a:pPr>
+              <a:spcBef>
+                <a:spcPct val="0"/>
+              </a:spcBef>
+              <a:buFontTx/>
+              <a:buNone/>
+            </a:pPr>
+            <a:r>
+              <a:rPr lang="en-US" altLang="en-US" sz="2800" dirty="0" err="1">
+                <a:latin typeface="Tahoma" panose="020B0604030504040204" pitchFamily="34" charset="0"/>
+              </a:rPr>
+              <a:t>out.println</a:t>
+            </a:r>
+            <a:r>
+              <a:rPr lang="en-US" altLang="en-US" sz="2800" dirty="0">
+                <a:latin typeface="Tahoma" panose="020B0604030504040204" pitchFamily="34" charset="0"/>
+              </a:rPr>
+              <a:t>(</a:t>
+            </a:r>
+            <a:r>
+              <a:rPr lang="en-US" altLang="en-US" sz="2800" dirty="0" err="1">
+                <a:latin typeface="Tahoma" panose="020B0604030504040204" pitchFamily="34" charset="0"/>
+              </a:rPr>
+              <a:t>queue.</a:t>
+            </a:r>
+            <a:r>
+              <a:rPr lang="en-US" altLang="en-US" sz="2800" dirty="0" err="1">
+                <a:solidFill>
+                  <a:srgbClr val="7030A0"/>
+                </a:solidFill>
+                <a:latin typeface="Tahoma" panose="020B0604030504040204" pitchFamily="34" charset="0"/>
+              </a:rPr>
+              <a:t>peek</a:t>
+            </a:r>
+            <a:r>
+              <a:rPr lang="en-US" altLang="en-US" sz="2800" dirty="0">
+                <a:solidFill>
+                  <a:srgbClr val="7030A0"/>
+                </a:solidFill>
+                <a:latin typeface="Tahoma" panose="020B0604030504040204" pitchFamily="34" charset="0"/>
+              </a:rPr>
+              <a:t>()</a:t>
+            </a:r>
+            <a:r>
+              <a:rPr lang="en-US" altLang="en-US" sz="2800" dirty="0">
+                <a:latin typeface="Tahoma" panose="020B0604030504040204" pitchFamily="34" charset="0"/>
+              </a:rPr>
+              <a:t>);</a:t>
+            </a:r>
+          </a:p>
+          <a:p>
+            <a:pPr>
+              <a:spcBef>
+                <a:spcPct val="0"/>
+              </a:spcBef>
+              <a:buFontTx/>
+              <a:buNone/>
+            </a:pPr>
+            <a:r>
+              <a:rPr lang="en-US" altLang="en-US" sz="2800" dirty="0" err="1">
+                <a:latin typeface="Tahoma" panose="020B0604030504040204" pitchFamily="34" charset="0"/>
+              </a:rPr>
+              <a:t>queue.</a:t>
+            </a:r>
+            <a:r>
+              <a:rPr lang="en-US" altLang="en-US" sz="2800" dirty="0" err="1">
+                <a:solidFill>
+                  <a:srgbClr val="7030A0"/>
+                </a:solidFill>
+                <a:latin typeface="Tahoma" panose="020B0604030504040204" pitchFamily="34" charset="0"/>
+              </a:rPr>
+              <a:t>poll</a:t>
+            </a:r>
+            <a:r>
+              <a:rPr lang="en-US" altLang="en-US" sz="2800" dirty="0">
+                <a:solidFill>
+                  <a:srgbClr val="7030A0"/>
+                </a:solidFill>
+                <a:latin typeface="Tahoma" panose="020B0604030504040204" pitchFamily="34" charset="0"/>
+              </a:rPr>
+              <a:t>()</a:t>
+            </a:r>
+            <a:r>
+              <a:rPr lang="en-US" altLang="en-US" sz="2800" dirty="0">
+                <a:latin typeface="Tahoma" panose="020B0604030504040204" pitchFamily="34" charset="0"/>
+              </a:rPr>
+              <a:t>;</a:t>
+            </a:r>
+          </a:p>
+          <a:p>
+            <a:pPr>
+              <a:spcBef>
+                <a:spcPct val="0"/>
+              </a:spcBef>
+              <a:buFontTx/>
+              <a:buNone/>
+            </a:pPr>
+            <a:r>
+              <a:rPr lang="en-US" altLang="en-US" sz="2800" dirty="0" err="1">
+                <a:latin typeface="Tahoma" panose="020B0604030504040204" pitchFamily="34" charset="0"/>
+              </a:rPr>
+              <a:t>out.println</a:t>
+            </a:r>
+            <a:r>
+              <a:rPr lang="en-US" altLang="en-US" sz="2800" dirty="0">
+                <a:latin typeface="Tahoma" panose="020B0604030504040204" pitchFamily="34" charset="0"/>
+              </a:rPr>
+              <a:t>(</a:t>
+            </a:r>
+            <a:r>
+              <a:rPr lang="en-US" altLang="en-US" sz="2800" dirty="0" err="1">
+                <a:latin typeface="Tahoma" panose="020B0604030504040204" pitchFamily="34" charset="0"/>
+              </a:rPr>
+              <a:t>queue.</a:t>
+            </a:r>
+            <a:r>
+              <a:rPr lang="en-US" altLang="en-US" sz="2800" dirty="0" err="1">
+                <a:solidFill>
+                  <a:srgbClr val="7030A0"/>
+                </a:solidFill>
+                <a:latin typeface="Tahoma" panose="020B0604030504040204" pitchFamily="34" charset="0"/>
+              </a:rPr>
+              <a:t>peek</a:t>
+            </a:r>
+            <a:r>
+              <a:rPr lang="en-US" altLang="en-US" sz="2800" dirty="0">
+                <a:solidFill>
+                  <a:srgbClr val="7030A0"/>
+                </a:solidFill>
+                <a:latin typeface="Tahoma" panose="020B0604030504040204" pitchFamily="34" charset="0"/>
+              </a:rPr>
+              <a:t>()</a:t>
+            </a:r>
+            <a:r>
+              <a:rPr lang="en-US" altLang="en-US" sz="2800" dirty="0">
+                <a:latin typeface="Tahoma" panose="020B0604030504040204" pitchFamily="34" charset="0"/>
+              </a:rPr>
+              <a:t>);</a:t>
+            </a:r>
+          </a:p>
+          <a:p>
+            <a:pPr>
+              <a:spcBef>
+                <a:spcPct val="0"/>
+              </a:spcBef>
+              <a:buFontTx/>
+              <a:buNone/>
+            </a:pPr>
+            <a:r>
+              <a:rPr lang="en-US" altLang="en-US" sz="2800" dirty="0" err="1">
+                <a:latin typeface="Tahoma" panose="020B0604030504040204" pitchFamily="34" charset="0"/>
+              </a:rPr>
+              <a:t>queue.</a:t>
+            </a:r>
+            <a:r>
+              <a:rPr lang="en-US" altLang="en-US" sz="2800" dirty="0" err="1">
+                <a:solidFill>
+                  <a:srgbClr val="7030A0"/>
+                </a:solidFill>
+                <a:latin typeface="Tahoma" panose="020B0604030504040204" pitchFamily="34" charset="0"/>
+              </a:rPr>
+              <a:t>poll</a:t>
+            </a:r>
+            <a:r>
+              <a:rPr lang="en-US" altLang="en-US" sz="2800" dirty="0">
+                <a:solidFill>
+                  <a:srgbClr val="7030A0"/>
+                </a:solidFill>
+                <a:latin typeface="Tahoma" panose="020B0604030504040204" pitchFamily="34" charset="0"/>
+              </a:rPr>
+              <a:t>()</a:t>
+            </a:r>
+            <a:r>
+              <a:rPr lang="en-US" altLang="en-US" sz="2800" dirty="0">
+                <a:latin typeface="Tahoma" panose="020B0604030504040204" pitchFamily="34" charset="0"/>
+              </a:rPr>
+              <a:t>;</a:t>
+            </a:r>
+          </a:p>
+          <a:p>
+            <a:pPr>
+              <a:spcBef>
+                <a:spcPct val="0"/>
+              </a:spcBef>
+              <a:buFontTx/>
+              <a:buNone/>
+            </a:pPr>
+            <a:r>
+              <a:rPr lang="en-US" altLang="en-US" sz="2800" dirty="0" err="1">
+                <a:latin typeface="Tahoma" panose="020B0604030504040204" pitchFamily="34" charset="0"/>
+              </a:rPr>
+              <a:t>out.println</a:t>
+            </a:r>
+            <a:r>
+              <a:rPr lang="en-US" altLang="en-US" sz="2800" dirty="0">
+                <a:latin typeface="Tahoma" panose="020B0604030504040204" pitchFamily="34" charset="0"/>
+              </a:rPr>
+              <a:t>(queue);</a:t>
+            </a:r>
+          </a:p>
+          <a:p>
+            <a:pPr>
+              <a:spcBef>
+                <a:spcPct val="0"/>
+              </a:spcBef>
+              <a:buFontTx/>
+              <a:buNone/>
+            </a:pPr>
+            <a:endParaRPr lang="en-US" altLang="en-US" sz="2800" dirty="0">
+              <a:latin typeface="Tahoma" panose="020B0604030504040204" pitchFamily="34" charset="0"/>
+            </a:endParaRPr>
+          </a:p>
+        </p:txBody>
+      </p:sp>
+      <p:sp>
+        <p:nvSpPr>
+          <p:cNvPr id="20485" name="Text Box 4">
+            <a:extLst>
+              <a:ext uri="{FF2B5EF4-FFF2-40B4-BE49-F238E27FC236}">
+                <a16:creationId xmlns:a16="http://schemas.microsoft.com/office/drawing/2014/main" id="{3AFAB5FD-4374-4D4F-972E-A0AA7FE62F3D}"/>
+              </a:ext>
+            </a:extLst>
+          </p:cNvPr>
+          <p:cNvSpPr txBox="1">
+            <a:spLocks noChangeArrowheads="1"/>
+          </p:cNvSpPr>
+          <p:nvPr/>
+        </p:nvSpPr>
+        <p:spPr bwMode="auto">
+          <a:xfrm>
+            <a:off x="6934200" y="3200400"/>
+            <a:ext cx="1905000" cy="2300288"/>
+          </a:xfrm>
+          <a:prstGeom prst="rect">
+            <a:avLst/>
+          </a:prstGeom>
+          <a:noFill/>
+          <a:ln w="12700">
+            <a:solidFill>
+              <a:srgbClr val="993300"/>
+            </a:solidFill>
+            <a:miter lim="800000"/>
+            <a:headEnd type="none" w="sm" len="sm"/>
+            <a:tailEnd type="none" w="sm" len="sm"/>
+          </a:ln>
+          <a:effectLst/>
+          <a:extLst>
+            <a:ext uri="{909E8E84-426E-40DD-AFC4-6F175D3DCCD1}">
+              <a14:hiddenFill xmlns:a14="http://schemas.microsoft.com/office/drawing/2010/main">
+                <a:solidFill>
+                  <a:schemeClr val="accent1"/>
+                </a:solidFill>
+              </a14:hiddenFill>
+            </a:ext>
+            <a:ext uri="{AF507438-7753-43E0-B8FC-AC1667EBCBE1}">
+              <a14:hiddenEffects xmlns:a14="http://schemas.microsoft.com/office/drawing/2010/main">
+                <a:effectLst>
+                  <a:outerShdw dist="35921" dir="2700000" algn="ctr" rotWithShape="0">
+                    <a:schemeClr val="bg2"/>
+                  </a:outerShdw>
+                </a:effectLst>
+              </a14:hiddenEffects>
+            </a:ext>
+          </a:extLst>
+        </p:spPr>
+        <p:txBody>
+          <a:bodyPr>
+            <a:spAutoFit/>
+          </a:bodyPr>
+          <a:lstStyle>
+            <a:lvl1pPr>
+              <a:spcBef>
+                <a:spcPct val="20000"/>
+              </a:spcBef>
+              <a:buChar char="•"/>
+              <a:defRPr sz="3200">
+                <a:solidFill>
+                  <a:schemeClr val="tx1"/>
+                </a:solidFill>
+                <a:latin typeface="Times New Roman" panose="02020603050405020304" pitchFamily="18" charset="0"/>
+              </a:defRPr>
+            </a:lvl1pPr>
+            <a:lvl2pPr marL="742950" indent="-285750">
+              <a:spcBef>
+                <a:spcPct val="20000"/>
+              </a:spcBef>
+              <a:buChar char="–"/>
+              <a:defRPr sz="2800">
+                <a:solidFill>
+                  <a:schemeClr val="tx1"/>
+                </a:solidFill>
+                <a:latin typeface="Times New Roman" panose="02020603050405020304" pitchFamily="18" charset="0"/>
+              </a:defRPr>
+            </a:lvl2pPr>
+            <a:lvl3pPr marL="1143000" indent="-228600">
+              <a:spcBef>
+                <a:spcPct val="20000"/>
+              </a:spcBef>
+              <a:buChar char="•"/>
+              <a:defRPr sz="2400">
+                <a:solidFill>
+                  <a:schemeClr val="tx1"/>
+                </a:solidFill>
+                <a:latin typeface="Times New Roman" panose="02020603050405020304" pitchFamily="18" charset="0"/>
+              </a:defRPr>
+            </a:lvl3pPr>
+            <a:lvl4pPr marL="1600200" indent="-228600">
+              <a:spcBef>
+                <a:spcPct val="20000"/>
+              </a:spcBef>
+              <a:buChar char="–"/>
+              <a:defRPr sz="2000">
+                <a:solidFill>
+                  <a:schemeClr val="tx1"/>
+                </a:solidFill>
+                <a:latin typeface="Times New Roman" panose="02020603050405020304" pitchFamily="18" charset="0"/>
+              </a:defRPr>
+            </a:lvl4pPr>
+            <a:lvl5pPr marL="2057400" indent="-228600">
+              <a:spcBef>
+                <a:spcPct val="20000"/>
+              </a:spcBef>
+              <a:buChar char="»"/>
+              <a:defRPr sz="2000">
+                <a:solidFill>
+                  <a:schemeClr val="tx1"/>
+                </a:solidFill>
+                <a:latin typeface="Times New Roman" panose="02020603050405020304" pitchFamily="18" charset="0"/>
+              </a:defRPr>
+            </a:lvl5pPr>
+            <a:lvl6pPr marL="2514600" indent="-228600" eaLnBrk="0" fontAlgn="base" hangingPunct="0">
+              <a:spcBef>
+                <a:spcPct val="20000"/>
+              </a:spcBef>
+              <a:spcAft>
+                <a:spcPct val="0"/>
+              </a:spcAft>
+              <a:buChar char="»"/>
+              <a:defRPr sz="2000">
+                <a:solidFill>
+                  <a:schemeClr val="tx1"/>
+                </a:solidFill>
+                <a:latin typeface="Times New Roman" panose="02020603050405020304" pitchFamily="18" charset="0"/>
+              </a:defRPr>
+            </a:lvl6pPr>
+            <a:lvl7pPr marL="2971800" indent="-228600" eaLnBrk="0" fontAlgn="base" hangingPunct="0">
+              <a:spcBef>
+                <a:spcPct val="20000"/>
+              </a:spcBef>
+              <a:spcAft>
+                <a:spcPct val="0"/>
+              </a:spcAft>
+              <a:buChar char="»"/>
+              <a:defRPr sz="2000">
+                <a:solidFill>
+                  <a:schemeClr val="tx1"/>
+                </a:solidFill>
+                <a:latin typeface="Times New Roman" panose="02020603050405020304" pitchFamily="18" charset="0"/>
+              </a:defRPr>
+            </a:lvl7pPr>
+            <a:lvl8pPr marL="3429000" indent="-228600" eaLnBrk="0" fontAlgn="base" hangingPunct="0">
+              <a:spcBef>
+                <a:spcPct val="20000"/>
+              </a:spcBef>
+              <a:spcAft>
+                <a:spcPct val="0"/>
+              </a:spcAft>
+              <a:buChar char="»"/>
+              <a:defRPr sz="2000">
+                <a:solidFill>
+                  <a:schemeClr val="tx1"/>
+                </a:solidFill>
+                <a:latin typeface="Times New Roman" panose="02020603050405020304" pitchFamily="18" charset="0"/>
+              </a:defRPr>
+            </a:lvl8pPr>
+            <a:lvl9pPr marL="3886200" indent="-228600" eaLnBrk="0" fontAlgn="base" hangingPunct="0">
+              <a:spcBef>
+                <a:spcPct val="20000"/>
+              </a:spcBef>
+              <a:spcAft>
+                <a:spcPct val="0"/>
+              </a:spcAft>
+              <a:buChar char="»"/>
+              <a:defRPr sz="2000">
+                <a:solidFill>
+                  <a:schemeClr val="tx1"/>
+                </a:solidFill>
+                <a:latin typeface="Times New Roman" panose="02020603050405020304" pitchFamily="18" charset="0"/>
+              </a:defRPr>
+            </a:lvl9pPr>
+          </a:lstStyle>
+          <a:p>
+            <a:pPr>
+              <a:spcBef>
+                <a:spcPct val="50000"/>
+              </a:spcBef>
+              <a:buFontTx/>
+              <a:buNone/>
+            </a:pPr>
+            <a:r>
+              <a:rPr lang="en-US" altLang="en-US" u="sng">
+                <a:solidFill>
+                  <a:srgbClr val="FF0000"/>
+                </a:solidFill>
+                <a:latin typeface="Tahoma" panose="020B0604030504040204" pitchFamily="34" charset="0"/>
+              </a:rPr>
+              <a:t>OUTPUT</a:t>
+            </a:r>
+          </a:p>
+          <a:p>
+            <a:pPr>
+              <a:spcBef>
+                <a:spcPct val="0"/>
+              </a:spcBef>
+              <a:buFontTx/>
+              <a:buNone/>
+            </a:pPr>
+            <a:r>
+              <a:rPr lang="en-US" altLang="en-US" sz="2800">
+                <a:latin typeface="Tahoma" panose="020B0604030504040204" pitchFamily="34" charset="0"/>
+              </a:rPr>
+              <a:t>[11, 7]</a:t>
+            </a:r>
+          </a:p>
+          <a:p>
+            <a:pPr>
+              <a:spcBef>
+                <a:spcPct val="0"/>
+              </a:spcBef>
+              <a:buFontTx/>
+              <a:buNone/>
+            </a:pPr>
+            <a:r>
+              <a:rPr lang="en-US" altLang="en-US" sz="2800">
+                <a:latin typeface="Tahoma" panose="020B0604030504040204" pitchFamily="34" charset="0"/>
+              </a:rPr>
+              <a:t>11</a:t>
+            </a:r>
+          </a:p>
+          <a:p>
+            <a:pPr>
+              <a:spcBef>
+                <a:spcPct val="0"/>
+              </a:spcBef>
+              <a:buFontTx/>
+              <a:buNone/>
+            </a:pPr>
+            <a:r>
+              <a:rPr lang="en-US" altLang="en-US" sz="2800">
+                <a:latin typeface="Tahoma" panose="020B0604030504040204" pitchFamily="34" charset="0"/>
+              </a:rPr>
+              <a:t>7</a:t>
+            </a:r>
+          </a:p>
+          <a:p>
+            <a:pPr>
+              <a:spcBef>
+                <a:spcPct val="0"/>
+              </a:spcBef>
+              <a:buFontTx/>
+              <a:buNone/>
+            </a:pPr>
+            <a:r>
+              <a:rPr lang="en-US" altLang="en-US" sz="2800">
+                <a:latin typeface="Tahoma" panose="020B0604030504040204" pitchFamily="34" charset="0"/>
+              </a:rPr>
+              <a:t>[]</a:t>
+            </a:r>
+          </a:p>
+        </p:txBody>
+      </p:sp>
+      <p:sp>
+        <p:nvSpPr>
+          <p:cNvPr id="2" name="Rectangle 1">
+            <a:extLst>
+              <a:ext uri="{FF2B5EF4-FFF2-40B4-BE49-F238E27FC236}">
+                <a16:creationId xmlns:a16="http://schemas.microsoft.com/office/drawing/2014/main" id="{2FC3ABB6-94C7-900D-A53E-630E96000229}"/>
+              </a:ext>
+            </a:extLst>
+          </p:cNvPr>
+          <p:cNvSpPr/>
+          <p:nvPr/>
+        </p:nvSpPr>
+        <p:spPr>
+          <a:xfrm>
+            <a:off x="1744403" y="338435"/>
+            <a:ext cx="5795176" cy="923330"/>
+          </a:xfrm>
+          <a:prstGeom prst="rect">
+            <a:avLst/>
+          </a:prstGeom>
+          <a:noFill/>
+        </p:spPr>
+        <p:txBody>
+          <a:bodyPr wrap="none" lIns="91440" tIns="45720" rIns="91440" bIns="45720">
+            <a:spAutoFit/>
+          </a:bodyPr>
+          <a:lstStyle/>
+          <a:p>
+            <a:pPr algn="ctr"/>
+            <a:r>
+              <a:rPr lang="en-US" sz="5400" b="1" cap="none" spc="0" dirty="0">
+                <a:ln w="12700" cmpd="sng">
+                  <a:solidFill>
+                    <a:schemeClr val="accent4"/>
+                  </a:solidFill>
+                  <a:prstDash val="solid"/>
+                </a:ln>
+                <a:gradFill>
+                  <a:gsLst>
+                    <a:gs pos="0">
+                      <a:schemeClr val="accent4"/>
+                    </a:gs>
+                    <a:gs pos="4000">
+                      <a:schemeClr val="accent4">
+                        <a:lumMod val="60000"/>
+                        <a:lumOff val="40000"/>
+                      </a:schemeClr>
+                    </a:gs>
+                    <a:gs pos="87000">
+                      <a:schemeClr val="accent4">
+                        <a:lumMod val="20000"/>
+                        <a:lumOff val="80000"/>
+                      </a:schemeClr>
+                    </a:gs>
+                  </a:gsLst>
+                  <a:lin ang="5400000"/>
+                </a:gradFill>
+                <a:effectLst/>
+              </a:rPr>
+              <a:t>Offer, Poll, Peek</a:t>
+            </a:r>
+          </a:p>
+        </p:txBody>
+      </p:sp>
+    </p:spTree>
+    <p:extLst>
+      <p:ext uri="{BB962C8B-B14F-4D97-AF65-F5344CB8AC3E}">
+        <p14:creationId xmlns:p14="http://schemas.microsoft.com/office/powerpoint/2010/main" val="1024084585"/>
+      </p:ext>
+    </p:extLst>
   </p:cSld>
   <p:clrMapOvr>
     <a:masterClrMapping/>

</xml_diff>